<commit_message>
Corregir paleta a los colores institucionales reales de Lions
El informe y la presentación usaban púrpura/dorado como aproximación
genérica de "colores de club social". Se reemplaza por los colores
oficiales de Lions Clubs International (azul #00338D y dorado
#FDB913), tomados del logo oficial que subió el usuario, ya que este
entorno no tiene acceso a internet para verificar el manual de marca.
Co-Authored-By: Claude Sonnet 5 <noreply@anthropic.com>
Claude-Session: https://claude.ai/code/session_01UWKZXqoHYVxY6r86dsip31
</commit_message>
<xml_diff>
--- a/informes/Presentacion_Modelo_Arriendo_Club_Leones_Z144.pptx
+++ b/informes/Presentacion_Modelo_Arriendo_Club_Leones_Z144.pptx
@@ -1658,7 +1658,7 @@
     <p:bg>
       <p:bgPr>
         <a:solidFill>
-          <a:srgbClr val="241033"/>
+          <a:srgbClr val="001233"/>
         </a:solidFill>
       </p:bgPr>
     </p:bg>
@@ -1691,7 +1691,7 @@
             <a:avLst/>
           </a:prstGeom>
           <a:solidFill>
-            <a:srgbClr val="3A1959"/>
+            <a:srgbClr val="0047AB"/>
           </a:solidFill>
           <a:ln/>
         </p:spPr>
@@ -1711,7 +1711,7 @@
             <a:avLst/>
           </a:prstGeom>
           <a:solidFill>
-            <a:srgbClr val="4B1F6F"/>
+            <a:srgbClr val="00338D"/>
           </a:solidFill>
           <a:ln/>
         </p:spPr>
@@ -1743,7 +1743,7 @@
             <a:r>
               <a:rPr lang="en-US" sz="1500" b="1" spc="300" kern="0" dirty="0">
                 <a:solidFill>
-                  <a:srgbClr val="C89B3C"/>
+                  <a:srgbClr val="FDB913"/>
                 </a:solidFill>
                 <a:latin typeface="Calibri" pitchFamily="34" charset="0"/>
                 <a:ea typeface="Calibri" pitchFamily="34" charset="-122"/>
@@ -1821,7 +1821,7 @@
             <a:r>
               <a:rPr lang="en-US" sz="2200" dirty="0">
                 <a:solidFill>
-                  <a:srgbClr val="F6EFDE"/>
+                  <a:srgbClr val="FFF6DF"/>
                 </a:solidFill>
                 <a:latin typeface="Calibri" pitchFamily="34" charset="0"/>
                 <a:ea typeface="Calibri" pitchFamily="34" charset="-122"/>
@@ -1887,7 +1887,7 @@
             <a:avLst/>
           </a:prstGeom>
           <a:solidFill>
-            <a:srgbClr val="C89B3C"/>
+            <a:srgbClr val="FDB913"/>
           </a:solidFill>
           <a:ln/>
         </p:spPr>
@@ -1969,7 +1969,7 @@
     <p:bg>
       <p:bgPr>
         <a:solidFill>
-          <a:srgbClr val="241033"/>
+          <a:srgbClr val="001233"/>
         </a:solidFill>
       </p:bgPr>
     </p:bg>
@@ -2002,7 +2002,7 @@
             <a:avLst/>
           </a:prstGeom>
           <a:solidFill>
-            <a:srgbClr val="3A1959"/>
+            <a:srgbClr val="0047AB"/>
           </a:solidFill>
           <a:ln/>
         </p:spPr>
@@ -2022,7 +2022,7 @@
             <a:avLst/>
           </a:prstGeom>
           <a:solidFill>
-            <a:srgbClr val="C89B3C"/>
+            <a:srgbClr val="FDB913"/>
           </a:solidFill>
           <a:ln/>
         </p:spPr>
@@ -2120,7 +2120,7 @@
             <a:r>
               <a:rPr lang="en-US" sz="1700" dirty="0">
                 <a:solidFill>
-                  <a:srgbClr val="F6EFDE"/>
+                  <a:srgbClr val="FFF6DF"/>
                 </a:solidFill>
                 <a:latin typeface="Calibri" pitchFamily="34" charset="0"/>
                 <a:ea typeface="Calibri" pitchFamily="34" charset="-122"/>
@@ -2147,7 +2147,7 @@
             <a:avLst/>
           </a:prstGeom>
           <a:solidFill>
-            <a:srgbClr val="3A1959"/>
+            <a:srgbClr val="0047AB"/>
           </a:solidFill>
           <a:ln/>
         </p:spPr>
@@ -2230,7 +2230,7 @@
             <a:avLst/>
           </a:prstGeom>
           <a:solidFill>
-            <a:srgbClr val="3A1959"/>
+            <a:srgbClr val="0047AB"/>
           </a:solidFill>
           <a:ln/>
         </p:spPr>
@@ -2313,7 +2313,7 @@
             <a:avLst/>
           </a:prstGeom>
           <a:solidFill>
-            <a:srgbClr val="3A1959"/>
+            <a:srgbClr val="0047AB"/>
           </a:solidFill>
           <a:ln/>
         </p:spPr>
@@ -2396,7 +2396,7 @@
             <a:avLst/>
           </a:prstGeom>
           <a:solidFill>
-            <a:srgbClr val="3A1959"/>
+            <a:srgbClr val="0047AB"/>
           </a:solidFill>
           <a:ln/>
         </p:spPr>
@@ -2562,7 +2562,7 @@
             <a:r>
               <a:rPr lang="en-US" sz="1300" b="1" spc="200" kern="0" dirty="0">
                 <a:solidFill>
-                  <a:srgbClr val="C89B3C"/>
+                  <a:srgbClr val="FDB913"/>
                 </a:solidFill>
                 <a:latin typeface="Calibri" pitchFamily="34" charset="0"/>
                 <a:ea typeface="Calibri" pitchFamily="34" charset="-122"/>
@@ -2601,7 +2601,7 @@
             <a:r>
               <a:rPr lang="en-US" sz="3000" b="1" dirty="0">
                 <a:solidFill>
-                  <a:srgbClr val="241033"/>
+                  <a:srgbClr val="001233"/>
                 </a:solidFill>
                 <a:latin typeface="Cambria" pitchFamily="34" charset="0"/>
                 <a:ea typeface="Cambria" pitchFamily="34" charset="-122"/>
@@ -2685,7 +2685,7 @@
             <a:r>
               <a:rPr lang="en-US" sz="1600" b="1" dirty="0">
                 <a:solidFill>
-                  <a:srgbClr val="241033"/>
+                  <a:srgbClr val="001233"/>
                 </a:solidFill>
                 <a:latin typeface="Calibri" pitchFamily="34" charset="0"/>
                 <a:ea typeface="Calibri" pitchFamily="34" charset="-122"/>
@@ -2731,7 +2731,7 @@
             </a:avLst>
           </a:prstGeom>
           <a:solidFill>
-            <a:srgbClr val="F1ECF6"/>
+            <a:srgbClr val="E9F0FA"/>
           </a:solidFill>
           <a:ln/>
           <a:effectLst>
@@ -2758,7 +2758,7 @@
             <a:avLst/>
           </a:prstGeom>
           <a:solidFill>
-            <a:srgbClr val="4B1F6F"/>
+            <a:srgbClr val="00338D"/>
           </a:solidFill>
           <a:ln/>
         </p:spPr>
@@ -2814,7 +2814,7 @@
             <a:r>
               <a:rPr lang="en-US" sz="1600" b="1" dirty="0">
                 <a:solidFill>
-                  <a:srgbClr val="241033"/>
+                  <a:srgbClr val="001233"/>
                 </a:solidFill>
                 <a:latin typeface="Calibri" pitchFamily="34" charset="0"/>
                 <a:ea typeface="Calibri" pitchFamily="34" charset="-122"/>
@@ -2853,7 +2853,7 @@
             <a:r>
               <a:rPr lang="en-US" sz="4000" b="1" dirty="0">
                 <a:solidFill>
-                  <a:srgbClr val="241033"/>
+                  <a:srgbClr val="001233"/>
                 </a:solidFill>
                 <a:latin typeface="Cambria" pitchFamily="34" charset="0"/>
                 <a:ea typeface="Cambria" pitchFamily="34" charset="-122"/>
@@ -3080,7 +3080,7 @@
             <a:r>
               <a:rPr lang="en-US" sz="1300" b="1" spc="200" kern="0" dirty="0">
                 <a:solidFill>
-                  <a:srgbClr val="C89B3C"/>
+                  <a:srgbClr val="FDB913"/>
                 </a:solidFill>
                 <a:latin typeface="Calibri" pitchFamily="34" charset="0"/>
                 <a:ea typeface="Calibri" pitchFamily="34" charset="-122"/>
@@ -3119,7 +3119,7 @@
             <a:r>
               <a:rPr lang="en-US" sz="3000" b="1" dirty="0">
                 <a:solidFill>
-                  <a:srgbClr val="241033"/>
+                  <a:srgbClr val="001233"/>
                 </a:solidFill>
                 <a:latin typeface="Cambria" pitchFamily="34" charset="0"/>
                 <a:ea typeface="Cambria" pitchFamily="34" charset="-122"/>
@@ -3148,7 +3148,7 @@
             </a:avLst>
           </a:prstGeom>
           <a:solidFill>
-            <a:srgbClr val="4B1F6F"/>
+            <a:srgbClr val="00338D"/>
           </a:solidFill>
           <a:ln/>
         </p:spPr>
@@ -3168,7 +3168,7 @@
             <a:avLst/>
           </a:prstGeom>
           <a:solidFill>
-            <a:srgbClr val="C89B3C"/>
+            <a:srgbClr val="FDB913"/>
           </a:solidFill>
           <a:ln/>
         </p:spPr>
@@ -3256,7 +3256,7 @@
             </a:avLst>
           </a:prstGeom>
           <a:solidFill>
-            <a:srgbClr val="F1ECF6"/>
+            <a:srgbClr val="E9F0FA"/>
           </a:solidFill>
           <a:ln/>
         </p:spPr>
@@ -3288,7 +3288,7 @@
             <a:r>
               <a:rPr lang="en-US" sz="3200" b="1" dirty="0">
                 <a:solidFill>
-                  <a:srgbClr val="241033"/>
+                  <a:srgbClr val="001233"/>
                 </a:solidFill>
                 <a:latin typeface="Cambria" pitchFamily="34" charset="0"/>
                 <a:ea typeface="Cambria" pitchFamily="34" charset="-122"/>
@@ -3356,7 +3356,7 @@
             </a:avLst>
           </a:prstGeom>
           <a:solidFill>
-            <a:srgbClr val="F1ECF6"/>
+            <a:srgbClr val="E9F0FA"/>
           </a:solidFill>
           <a:ln/>
         </p:spPr>
@@ -3388,7 +3388,7 @@
             <a:r>
               <a:rPr lang="en-US" sz="3200" b="1" dirty="0">
                 <a:solidFill>
-                  <a:srgbClr val="241033"/>
+                  <a:srgbClr val="001233"/>
                 </a:solidFill>
                 <a:latin typeface="Cambria" pitchFamily="34" charset="0"/>
                 <a:ea typeface="Cambria" pitchFamily="34" charset="-122"/>
@@ -3456,7 +3456,7 @@
             </a:avLst>
           </a:prstGeom>
           <a:solidFill>
-            <a:srgbClr val="F1ECF6"/>
+            <a:srgbClr val="E9F0FA"/>
           </a:solidFill>
           <a:ln/>
         </p:spPr>
@@ -3488,7 +3488,7 @@
             <a:r>
               <a:rPr lang="en-US" sz="3200" b="1" dirty="0">
                 <a:solidFill>
-                  <a:srgbClr val="241033"/>
+                  <a:srgbClr val="001233"/>
                 </a:solidFill>
                 <a:latin typeface="Cambria" pitchFamily="34" charset="0"/>
                 <a:ea typeface="Cambria" pitchFamily="34" charset="-122"/>
@@ -3556,7 +3556,7 @@
             </a:avLst>
           </a:prstGeom>
           <a:solidFill>
-            <a:srgbClr val="F1ECF6"/>
+            <a:srgbClr val="E9F0FA"/>
           </a:solidFill>
           <a:ln/>
         </p:spPr>
@@ -3588,7 +3588,7 @@
             <a:r>
               <a:rPr lang="en-US" sz="3200" b="1" dirty="0">
                 <a:solidFill>
-                  <a:srgbClr val="241033"/>
+                  <a:srgbClr val="001233"/>
                 </a:solidFill>
                 <a:latin typeface="Cambria" pitchFamily="34" charset="0"/>
                 <a:ea typeface="Cambria" pitchFamily="34" charset="-122"/>
@@ -3776,7 +3776,7 @@
             <a:r>
               <a:rPr lang="en-US" sz="1300" b="1" spc="200" kern="0" dirty="0">
                 <a:solidFill>
-                  <a:srgbClr val="C89B3C"/>
+                  <a:srgbClr val="FDB913"/>
                 </a:solidFill>
                 <a:latin typeface="Calibri" pitchFamily="34" charset="0"/>
                 <a:ea typeface="Calibri" pitchFamily="34" charset="-122"/>
@@ -3815,7 +3815,7 @@
             <a:r>
               <a:rPr lang="en-US" sz="3000" b="1" dirty="0">
                 <a:solidFill>
-                  <a:srgbClr val="241033"/>
+                  <a:srgbClr val="001233"/>
                 </a:solidFill>
                 <a:latin typeface="Cambria" pitchFamily="34" charset="0"/>
                 <a:ea typeface="Cambria" pitchFamily="34" charset="-122"/>
@@ -3842,7 +3842,7 @@
             <a:avLst/>
           </a:prstGeom>
           <a:solidFill>
-            <a:srgbClr val="4B1F6F"/>
+            <a:srgbClr val="00338D"/>
           </a:solidFill>
           <a:ln/>
         </p:spPr>
@@ -3928,7 +3928,7 @@
             <a:avLst/>
           </a:prstGeom>
           <a:solidFill>
-            <a:srgbClr val="4B1F6F"/>
+            <a:srgbClr val="00338D"/>
           </a:solidFill>
           <a:ln/>
         </p:spPr>
@@ -4014,7 +4014,7 @@
             <a:avLst/>
           </a:prstGeom>
           <a:solidFill>
-            <a:srgbClr val="4B1F6F"/>
+            <a:srgbClr val="00338D"/>
           </a:solidFill>
           <a:ln/>
         </p:spPr>
@@ -4100,7 +4100,7 @@
             <a:avLst/>
           </a:prstGeom>
           <a:solidFill>
-            <a:srgbClr val="4B1F6F"/>
+            <a:srgbClr val="00338D"/>
           </a:solidFill>
           <a:ln/>
         </p:spPr>
@@ -4186,7 +4186,7 @@
             <a:avLst/>
           </a:prstGeom>
           <a:solidFill>
-            <a:srgbClr val="4B1F6F"/>
+            <a:srgbClr val="00338D"/>
           </a:solidFill>
           <a:ln/>
         </p:spPr>
@@ -4394,7 +4394,7 @@
             <a:r>
               <a:rPr lang="en-US" sz="1300" b="1" spc="200" kern="0" dirty="0">
                 <a:solidFill>
-                  <a:srgbClr val="C89B3C"/>
+                  <a:srgbClr val="FDB913"/>
                 </a:solidFill>
                 <a:latin typeface="Calibri" pitchFamily="34" charset="0"/>
                 <a:ea typeface="Calibri" pitchFamily="34" charset="-122"/>
@@ -4433,7 +4433,7 @@
             <a:r>
               <a:rPr lang="en-US" sz="3000" b="1" dirty="0">
                 <a:solidFill>
-                  <a:srgbClr val="241033"/>
+                  <a:srgbClr val="001233"/>
                 </a:solidFill>
                 <a:latin typeface="Cambria" pitchFamily="34" charset="0"/>
                 <a:ea typeface="Cambria" pitchFamily="34" charset="-122"/>
@@ -4501,7 +4501,7 @@
             </a:avLst>
           </a:prstGeom>
           <a:solidFill>
-            <a:srgbClr val="F1ECF6"/>
+            <a:srgbClr val="E9F0FA"/>
           </a:solidFill>
           <a:ln/>
         </p:spPr>
@@ -4533,7 +4533,7 @@
             <a:r>
               <a:rPr lang="en-US" sz="1700" b="1" dirty="0">
                 <a:solidFill>
-                  <a:srgbClr val="241033"/>
+                  <a:srgbClr val="001233"/>
                 </a:solidFill>
                 <a:latin typeface="Calibri" pitchFamily="34" charset="0"/>
                 <a:ea typeface="Calibri" pitchFamily="34" charset="-122"/>
@@ -4680,7 +4680,7 @@
             </a:avLst>
           </a:prstGeom>
           <a:solidFill>
-            <a:srgbClr val="F6EFDE"/>
+            <a:srgbClr val="FFF6DF"/>
           </a:solidFill>
           <a:ln/>
         </p:spPr>
@@ -4712,7 +4712,7 @@
             <a:r>
               <a:rPr lang="en-US" sz="1700" b="1" dirty="0">
                 <a:solidFill>
-                  <a:srgbClr val="241033"/>
+                  <a:srgbClr val="001233"/>
                 </a:solidFill>
                 <a:latin typeface="Calibri" pitchFamily="34" charset="0"/>
                 <a:ea typeface="Calibri" pitchFamily="34" charset="-122"/>
@@ -4979,7 +4979,7 @@
             <a:r>
               <a:rPr lang="en-US" sz="1300" b="1" spc="200" kern="0" dirty="0">
                 <a:solidFill>
-                  <a:srgbClr val="C89B3C"/>
+                  <a:srgbClr val="FDB913"/>
                 </a:solidFill>
                 <a:latin typeface="Calibri" pitchFamily="34" charset="0"/>
                 <a:ea typeface="Calibri" pitchFamily="34" charset="-122"/>
@@ -5018,7 +5018,7 @@
             <a:r>
               <a:rPr lang="en-US" sz="3000" b="1" dirty="0">
                 <a:solidFill>
-                  <a:srgbClr val="241033"/>
+                  <a:srgbClr val="001233"/>
                 </a:solidFill>
                 <a:latin typeface="Cambria" pitchFamily="34" charset="0"/>
                 <a:ea typeface="Cambria" pitchFamily="34" charset="-122"/>
@@ -5124,7 +5124,7 @@
                       <a:tailEnd type="none" w="med" len="med"/>
                     </a:lnB>
                     <a:solidFill>
-                      <a:srgbClr val="4B1F6F"/>
+                      <a:srgbClr val="00338D"/>
                     </a:solidFill>
                   </a:tcPr>
                 </a:tc>
@@ -5192,7 +5192,7 @@
                       <a:tailEnd type="none" w="med" len="med"/>
                     </a:lnB>
                     <a:solidFill>
-                      <a:srgbClr val="4B1F6F"/>
+                      <a:srgbClr val="00338D"/>
                     </a:solidFill>
                   </a:tcPr>
                 </a:tc>
@@ -5260,7 +5260,7 @@
                       <a:tailEnd type="none" w="med" len="med"/>
                     </a:lnB>
                     <a:solidFill>
-                      <a:srgbClr val="4B1F6F"/>
+                      <a:srgbClr val="00338D"/>
                     </a:solidFill>
                   </a:tcPr>
                 </a:tc>
@@ -5328,7 +5328,7 @@
                       <a:tailEnd type="none" w="med" len="med"/>
                     </a:lnB>
                     <a:solidFill>
-                      <a:srgbClr val="4B1F6F"/>
+                      <a:srgbClr val="00338D"/>
                     </a:solidFill>
                   </a:tcPr>
                 </a:tc>
@@ -5396,7 +5396,7 @@
                       <a:tailEnd type="none" w="med" len="med"/>
                     </a:lnB>
                     <a:solidFill>
-                      <a:srgbClr val="4B1F6F"/>
+                      <a:srgbClr val="00338D"/>
                     </a:solidFill>
                   </a:tcPr>
                 </a:tc>
@@ -5466,7 +5466,7 @@
                       <a:tailEnd type="none" w="med" len="med"/>
                     </a:lnB>
                     <a:solidFill>
-                      <a:srgbClr val="F1ECF6"/>
+                      <a:srgbClr val="E9F0FA"/>
                     </a:solidFill>
                   </a:tcPr>
                 </a:tc>
@@ -5534,7 +5534,7 @@
                       <a:tailEnd type="none" w="med" len="med"/>
                     </a:lnB>
                     <a:solidFill>
-                      <a:srgbClr val="F1ECF6"/>
+                      <a:srgbClr val="E9F0FA"/>
                     </a:solidFill>
                   </a:tcPr>
                 </a:tc>
@@ -5602,7 +5602,7 @@
                       <a:tailEnd type="none" w="med" len="med"/>
                     </a:lnB>
                     <a:solidFill>
-                      <a:srgbClr val="F1ECF6"/>
+                      <a:srgbClr val="E9F0FA"/>
                     </a:solidFill>
                   </a:tcPr>
                 </a:tc>
@@ -5670,7 +5670,7 @@
                       <a:tailEnd type="none" w="med" len="med"/>
                     </a:lnB>
                     <a:solidFill>
-                      <a:srgbClr val="F1ECF6"/>
+                      <a:srgbClr val="E9F0FA"/>
                     </a:solidFill>
                   </a:tcPr>
                 </a:tc>
@@ -5738,7 +5738,7 @@
                       <a:tailEnd type="none" w="med" len="med"/>
                     </a:lnB>
                     <a:solidFill>
-                      <a:srgbClr val="F1ECF6"/>
+                      <a:srgbClr val="E9F0FA"/>
                     </a:solidFill>
                   </a:tcPr>
                 </a:tc>
@@ -6150,7 +6150,7 @@
                       <a:tailEnd type="none" w="med" len="med"/>
                     </a:lnB>
                     <a:solidFill>
-                      <a:srgbClr val="F1ECF6"/>
+                      <a:srgbClr val="E9F0FA"/>
                     </a:solidFill>
                   </a:tcPr>
                 </a:tc>
@@ -6218,7 +6218,7 @@
                       <a:tailEnd type="none" w="med" len="med"/>
                     </a:lnB>
                     <a:solidFill>
-                      <a:srgbClr val="F1ECF6"/>
+                      <a:srgbClr val="E9F0FA"/>
                     </a:solidFill>
                   </a:tcPr>
                 </a:tc>
@@ -6286,7 +6286,7 @@
                       <a:tailEnd type="none" w="med" len="med"/>
                     </a:lnB>
                     <a:solidFill>
-                      <a:srgbClr val="F1ECF6"/>
+                      <a:srgbClr val="E9F0FA"/>
                     </a:solidFill>
                   </a:tcPr>
                 </a:tc>
@@ -6354,7 +6354,7 @@
                       <a:tailEnd type="none" w="med" len="med"/>
                     </a:lnB>
                     <a:solidFill>
-                      <a:srgbClr val="F1ECF6"/>
+                      <a:srgbClr val="E9F0FA"/>
                     </a:solidFill>
                   </a:tcPr>
                 </a:tc>
@@ -6422,7 +6422,7 @@
                       <a:tailEnd type="none" w="med" len="med"/>
                     </a:lnB>
                     <a:solidFill>
-                      <a:srgbClr val="F1ECF6"/>
+                      <a:srgbClr val="E9F0FA"/>
                     </a:solidFill>
                   </a:tcPr>
                 </a:tc>
@@ -6448,7 +6448,7 @@
             </a:avLst>
           </a:prstGeom>
           <a:solidFill>
-            <a:srgbClr val="F6EFDE"/>
+            <a:srgbClr val="FFF6DF"/>
           </a:solidFill>
           <a:ln/>
         </p:spPr>
@@ -6483,7 +6483,7 @@
             <a:r>
               <a:rPr lang="en-US" sz="1400" b="1" dirty="0">
                 <a:solidFill>
-                  <a:srgbClr val="241033"/>
+                  <a:srgbClr val="001233"/>
                 </a:solidFill>
                 <a:latin typeface="Calibri" pitchFamily="34" charset="0"/>
                 <a:ea typeface="Calibri" pitchFamily="34" charset="-122"/>
@@ -6688,7 +6688,7 @@
             <a:r>
               <a:rPr lang="en-US" sz="1300" b="1" spc="200" kern="0" dirty="0">
                 <a:solidFill>
-                  <a:srgbClr val="C89B3C"/>
+                  <a:srgbClr val="FDB913"/>
                 </a:solidFill>
                 <a:latin typeface="Calibri" pitchFamily="34" charset="0"/>
                 <a:ea typeface="Calibri" pitchFamily="34" charset="-122"/>
@@ -6727,7 +6727,7 @@
             <a:r>
               <a:rPr lang="en-US" sz="3000" b="1" dirty="0">
                 <a:solidFill>
-                  <a:srgbClr val="241033"/>
+                  <a:srgbClr val="001233"/>
                 </a:solidFill>
                 <a:latin typeface="Cambria" pitchFamily="34" charset="0"/>
                 <a:ea typeface="Cambria" pitchFamily="34" charset="-122"/>
@@ -6756,7 +6756,7 @@
             </a:avLst>
           </a:prstGeom>
           <a:solidFill>
-            <a:srgbClr val="F1ECF6"/>
+            <a:srgbClr val="E9F0FA"/>
           </a:solidFill>
           <a:ln/>
         </p:spPr>
@@ -6776,7 +6776,7 @@
             <a:avLst/>
           </a:prstGeom>
           <a:solidFill>
-            <a:srgbClr val="4B1F6F"/>
+            <a:srgbClr val="00338D"/>
           </a:solidFill>
           <a:ln/>
         </p:spPr>
@@ -6832,7 +6832,7 @@
             <a:r>
               <a:rPr lang="en-US" sz="1700" b="1" dirty="0">
                 <a:solidFill>
-                  <a:srgbClr val="241033"/>
+                  <a:srgbClr val="001233"/>
                 </a:solidFill>
                 <a:latin typeface="Calibri" pitchFamily="34" charset="0"/>
                 <a:ea typeface="Calibri" pitchFamily="34" charset="-122"/>
@@ -6943,7 +6943,7 @@
             </a:avLst>
           </a:prstGeom>
           <a:solidFill>
-            <a:srgbClr val="F1ECF6"/>
+            <a:srgbClr val="E9F0FA"/>
           </a:solidFill>
           <a:ln/>
         </p:spPr>
@@ -6963,7 +6963,7 @@
             <a:avLst/>
           </a:prstGeom>
           <a:solidFill>
-            <a:srgbClr val="4B1F6F"/>
+            <a:srgbClr val="00338D"/>
           </a:solidFill>
           <a:ln/>
         </p:spPr>
@@ -7019,7 +7019,7 @@
             <a:r>
               <a:rPr lang="en-US" sz="1700" b="1" dirty="0">
                 <a:solidFill>
-                  <a:srgbClr val="241033"/>
+                  <a:srgbClr val="001233"/>
                 </a:solidFill>
                 <a:latin typeface="Calibri" pitchFamily="34" charset="0"/>
                 <a:ea typeface="Calibri" pitchFamily="34" charset="-122"/>
@@ -7130,7 +7130,7 @@
             </a:avLst>
           </a:prstGeom>
           <a:solidFill>
-            <a:srgbClr val="F1ECF6"/>
+            <a:srgbClr val="E9F0FA"/>
           </a:solidFill>
           <a:ln/>
         </p:spPr>
@@ -7150,7 +7150,7 @@
             <a:avLst/>
           </a:prstGeom>
           <a:solidFill>
-            <a:srgbClr val="4B1F6F"/>
+            <a:srgbClr val="00338D"/>
           </a:solidFill>
           <a:ln/>
         </p:spPr>
@@ -7206,7 +7206,7 @@
             <a:r>
               <a:rPr lang="en-US" sz="1700" b="1" dirty="0">
                 <a:solidFill>
-                  <a:srgbClr val="241033"/>
+                  <a:srgbClr val="001233"/>
                 </a:solidFill>
                 <a:latin typeface="Calibri" pitchFamily="34" charset="0"/>
                 <a:ea typeface="Calibri" pitchFamily="34" charset="-122"/>
@@ -7437,7 +7437,7 @@
             <a:r>
               <a:rPr lang="en-US" sz="1300" b="1" spc="200" kern="0" dirty="0">
                 <a:solidFill>
-                  <a:srgbClr val="C89B3C"/>
+                  <a:srgbClr val="FDB913"/>
                 </a:solidFill>
                 <a:latin typeface="Calibri" pitchFamily="34" charset="0"/>
                 <a:ea typeface="Calibri" pitchFamily="34" charset="-122"/>
@@ -7476,7 +7476,7 @@
             <a:r>
               <a:rPr lang="en-US" sz="3000" b="1" dirty="0">
                 <a:solidFill>
-                  <a:srgbClr val="241033"/>
+                  <a:srgbClr val="001233"/>
                 </a:solidFill>
                 <a:latin typeface="Cambria" pitchFamily="34" charset="0"/>
                 <a:ea typeface="Cambria" pitchFamily="34" charset="-122"/>
@@ -7618,7 +7618,7 @@
                       <a:tailEnd type="none" w="med" len="med"/>
                     </a:lnB>
                     <a:solidFill>
-                      <a:srgbClr val="4B1F6F"/>
+                      <a:srgbClr val="00338D"/>
                     </a:solidFill>
                   </a:tcPr>
                 </a:tc>
@@ -7686,7 +7686,7 @@
                       <a:tailEnd type="none" w="med" len="med"/>
                     </a:lnB>
                     <a:solidFill>
-                      <a:srgbClr val="4B1F6F"/>
+                      <a:srgbClr val="00338D"/>
                     </a:solidFill>
                   </a:tcPr>
                 </a:tc>
@@ -7756,7 +7756,7 @@
                       <a:tailEnd type="none" w="med" len="med"/>
                     </a:lnB>
                     <a:solidFill>
-                      <a:srgbClr val="F1ECF6"/>
+                      <a:srgbClr val="E9F0FA"/>
                     </a:solidFill>
                   </a:tcPr>
                 </a:tc>
@@ -7824,7 +7824,7 @@
                       <a:tailEnd type="none" w="med" len="med"/>
                     </a:lnB>
                     <a:solidFill>
-                      <a:srgbClr val="F1ECF6"/>
+                      <a:srgbClr val="E9F0FA"/>
                     </a:solidFill>
                   </a:tcPr>
                 </a:tc>
@@ -8032,7 +8032,7 @@
                       <a:tailEnd type="none" w="med" len="med"/>
                     </a:lnB>
                     <a:solidFill>
-                      <a:srgbClr val="F1ECF6"/>
+                      <a:srgbClr val="E9F0FA"/>
                     </a:solidFill>
                   </a:tcPr>
                 </a:tc>
@@ -8100,7 +8100,7 @@
                       <a:tailEnd type="none" w="med" len="med"/>
                     </a:lnB>
                     <a:solidFill>
-                      <a:srgbClr val="F1ECF6"/>
+                      <a:srgbClr val="E9F0FA"/>
                     </a:solidFill>
                   </a:tcPr>
                 </a:tc>
@@ -8308,7 +8308,7 @@
                       <a:tailEnd type="none" w="med" len="med"/>
                     </a:lnB>
                     <a:solidFill>
-                      <a:srgbClr val="F1ECF6"/>
+                      <a:srgbClr val="E9F0FA"/>
                     </a:solidFill>
                   </a:tcPr>
                 </a:tc>
@@ -8376,7 +8376,7 @@
                       <a:tailEnd type="none" w="med" len="med"/>
                     </a:lnB>
                     <a:solidFill>
-                      <a:srgbClr val="F1ECF6"/>
+                      <a:srgbClr val="E9F0FA"/>
                     </a:solidFill>
                   </a:tcPr>
                 </a:tc>
@@ -8660,7 +8660,7 @@
             <a:r>
               <a:rPr lang="en-US" sz="1300" b="1" spc="200" kern="0" dirty="0">
                 <a:solidFill>
-                  <a:srgbClr val="C89B3C"/>
+                  <a:srgbClr val="FDB913"/>
                 </a:solidFill>
                 <a:latin typeface="Calibri" pitchFamily="34" charset="0"/>
                 <a:ea typeface="Calibri" pitchFamily="34" charset="-122"/>
@@ -8699,7 +8699,7 @@
             <a:r>
               <a:rPr lang="en-US" sz="3000" b="1" dirty="0">
                 <a:solidFill>
-                  <a:srgbClr val="241033"/>
+                  <a:srgbClr val="001233"/>
                 </a:solidFill>
                 <a:latin typeface="Cambria" pitchFamily="34" charset="0"/>
                 <a:ea typeface="Cambria" pitchFamily="34" charset="-122"/>
@@ -8728,7 +8728,7 @@
           <a:noFill/>
           <a:ln w="31750">
             <a:solidFill>
-              <a:srgbClr val="C89B3C"/>
+              <a:srgbClr val="FDB913"/>
             </a:solidFill>
             <a:prstDash val="dash"/>
           </a:ln>
@@ -8749,7 +8749,7 @@
             <a:avLst/>
           </a:prstGeom>
           <a:solidFill>
-            <a:srgbClr val="4B1F6F"/>
+            <a:srgbClr val="00338D"/>
           </a:solidFill>
           <a:ln w="25400">
             <a:solidFill>
@@ -8815,7 +8815,7 @@
             </a:avLst>
           </a:prstGeom>
           <a:solidFill>
-            <a:srgbClr val="F1ECF6"/>
+            <a:srgbClr val="E9F0FA"/>
           </a:solidFill>
           <a:ln/>
         </p:spPr>
@@ -8847,7 +8847,7 @@
             <a:r>
               <a:rPr lang="en-US" sz="1200" b="1" dirty="0">
                 <a:solidFill>
-                  <a:srgbClr val="9C7627"/>
+                  <a:srgbClr val="B8860B"/>
                 </a:solidFill>
                 <a:latin typeface="Calibri" pitchFamily="34" charset="0"/>
                 <a:ea typeface="Calibri" pitchFamily="34" charset="-122"/>
@@ -8886,7 +8886,7 @@
             <a:r>
               <a:rPr lang="en-US" sz="1600" b="1" dirty="0">
                 <a:solidFill>
-                  <a:srgbClr val="241033"/>
+                  <a:srgbClr val="001233"/>
                 </a:solidFill>
                 <a:latin typeface="Calibri" pitchFamily="34" charset="0"/>
                 <a:ea typeface="Calibri" pitchFamily="34" charset="-122"/>
@@ -8952,7 +8952,7 @@
             <a:avLst/>
           </a:prstGeom>
           <a:solidFill>
-            <a:srgbClr val="4B1F6F"/>
+            <a:srgbClr val="00338D"/>
           </a:solidFill>
           <a:ln w="25400">
             <a:solidFill>
@@ -9018,7 +9018,7 @@
             </a:avLst>
           </a:prstGeom>
           <a:solidFill>
-            <a:srgbClr val="F1ECF6"/>
+            <a:srgbClr val="E9F0FA"/>
           </a:solidFill>
           <a:ln/>
         </p:spPr>
@@ -9050,7 +9050,7 @@
             <a:r>
               <a:rPr lang="en-US" sz="1200" b="1" dirty="0">
                 <a:solidFill>
-                  <a:srgbClr val="9C7627"/>
+                  <a:srgbClr val="B8860B"/>
                 </a:solidFill>
                 <a:latin typeface="Calibri" pitchFamily="34" charset="0"/>
                 <a:ea typeface="Calibri" pitchFamily="34" charset="-122"/>
@@ -9089,7 +9089,7 @@
             <a:r>
               <a:rPr lang="en-US" sz="1600" b="1" dirty="0">
                 <a:solidFill>
-                  <a:srgbClr val="241033"/>
+                  <a:srgbClr val="001233"/>
                 </a:solidFill>
                 <a:latin typeface="Calibri" pitchFamily="34" charset="0"/>
                 <a:ea typeface="Calibri" pitchFamily="34" charset="-122"/>
@@ -9155,7 +9155,7 @@
             <a:avLst/>
           </a:prstGeom>
           <a:solidFill>
-            <a:srgbClr val="4B1F6F"/>
+            <a:srgbClr val="00338D"/>
           </a:solidFill>
           <a:ln w="25400">
             <a:solidFill>
@@ -9221,7 +9221,7 @@
             </a:avLst>
           </a:prstGeom>
           <a:solidFill>
-            <a:srgbClr val="F1ECF6"/>
+            <a:srgbClr val="E9F0FA"/>
           </a:solidFill>
           <a:ln/>
         </p:spPr>
@@ -9253,7 +9253,7 @@
             <a:r>
               <a:rPr lang="en-US" sz="1200" b="1" dirty="0">
                 <a:solidFill>
-                  <a:srgbClr val="9C7627"/>
+                  <a:srgbClr val="B8860B"/>
                 </a:solidFill>
                 <a:latin typeface="Calibri" pitchFamily="34" charset="0"/>
                 <a:ea typeface="Calibri" pitchFamily="34" charset="-122"/>
@@ -9292,7 +9292,7 @@
             <a:r>
               <a:rPr lang="en-US" sz="1600" b="1" dirty="0">
                 <a:solidFill>
-                  <a:srgbClr val="241033"/>
+                  <a:srgbClr val="001233"/>
                 </a:solidFill>
                 <a:latin typeface="Calibri" pitchFamily="34" charset="0"/>
                 <a:ea typeface="Calibri" pitchFamily="34" charset="-122"/>
@@ -9358,7 +9358,7 @@
             <a:avLst/>
           </a:prstGeom>
           <a:solidFill>
-            <a:srgbClr val="4B1F6F"/>
+            <a:srgbClr val="00338D"/>
           </a:solidFill>
           <a:ln w="25400">
             <a:solidFill>
@@ -9424,7 +9424,7 @@
             </a:avLst>
           </a:prstGeom>
           <a:solidFill>
-            <a:srgbClr val="F1ECF6"/>
+            <a:srgbClr val="E9F0FA"/>
           </a:solidFill>
           <a:ln/>
         </p:spPr>
@@ -9456,7 +9456,7 @@
             <a:r>
               <a:rPr lang="en-US" sz="1200" b="1" dirty="0">
                 <a:solidFill>
-                  <a:srgbClr val="9C7627"/>
+                  <a:srgbClr val="B8860B"/>
                 </a:solidFill>
                 <a:latin typeface="Calibri" pitchFamily="34" charset="0"/>
                 <a:ea typeface="Calibri" pitchFamily="34" charset="-122"/>
@@ -9495,7 +9495,7 @@
             <a:r>
               <a:rPr lang="en-US" sz="1600" b="1" dirty="0">
                 <a:solidFill>
-                  <a:srgbClr val="241033"/>
+                  <a:srgbClr val="001233"/>
                 </a:solidFill>
                 <a:latin typeface="Calibri" pitchFamily="34" charset="0"/>
                 <a:ea typeface="Calibri" pitchFamily="34" charset="-122"/>
@@ -9573,7 +9573,7 @@
             <a:r>
               <a:rPr lang="en-US" sz="1600" b="1" dirty="0">
                 <a:solidFill>
-                  <a:srgbClr val="241033"/>
+                  <a:srgbClr val="001233"/>
                 </a:solidFill>
                 <a:latin typeface="Calibri" pitchFamily="34" charset="0"/>
                 <a:ea typeface="Calibri" pitchFamily="34" charset="-122"/>
@@ -9600,7 +9600,7 @@
             <a:avLst/>
           </a:prstGeom>
           <a:solidFill>
-            <a:srgbClr val="4B1F6F"/>
+            <a:srgbClr val="00338D"/>
           </a:solidFill>
           <a:ln/>
         </p:spPr>
@@ -9656,7 +9656,7 @@
             <a:r>
               <a:rPr lang="en-US" sz="1300" b="1" dirty="0">
                 <a:solidFill>
-                  <a:srgbClr val="241033"/>
+                  <a:srgbClr val="001233"/>
                 </a:solidFill>
                 <a:latin typeface="Calibri" pitchFamily="34" charset="0"/>
                 <a:ea typeface="Calibri" pitchFamily="34" charset="-122"/>
@@ -9722,7 +9722,7 @@
             <a:avLst/>
           </a:prstGeom>
           <a:solidFill>
-            <a:srgbClr val="4B1F6F"/>
+            <a:srgbClr val="00338D"/>
           </a:solidFill>
           <a:ln/>
         </p:spPr>
@@ -9778,7 +9778,7 @@
             <a:r>
               <a:rPr lang="en-US" sz="1300" b="1" dirty="0">
                 <a:solidFill>
-                  <a:srgbClr val="241033"/>
+                  <a:srgbClr val="001233"/>
                 </a:solidFill>
                 <a:latin typeface="Calibri" pitchFamily="34" charset="0"/>
                 <a:ea typeface="Calibri" pitchFamily="34" charset="-122"/>
@@ -9844,7 +9844,7 @@
             <a:avLst/>
           </a:prstGeom>
           <a:solidFill>
-            <a:srgbClr val="4B1F6F"/>
+            <a:srgbClr val="00338D"/>
           </a:solidFill>
           <a:ln/>
         </p:spPr>
@@ -9900,7 +9900,7 @@
             <a:r>
               <a:rPr lang="en-US" sz="1300" b="1" dirty="0">
                 <a:solidFill>
-                  <a:srgbClr val="241033"/>
+                  <a:srgbClr val="001233"/>
                 </a:solidFill>
                 <a:latin typeface="Calibri" pitchFamily="34" charset="0"/>
                 <a:ea typeface="Calibri" pitchFamily="34" charset="-122"/>
@@ -9966,7 +9966,7 @@
             <a:avLst/>
           </a:prstGeom>
           <a:solidFill>
-            <a:srgbClr val="4B1F6F"/>
+            <a:srgbClr val="00338D"/>
           </a:solidFill>
           <a:ln/>
         </p:spPr>
@@ -10022,7 +10022,7 @@
             <a:r>
               <a:rPr lang="en-US" sz="1300" b="1" dirty="0">
                 <a:solidFill>
-                  <a:srgbClr val="241033"/>
+                  <a:srgbClr val="001233"/>
                 </a:solidFill>
                 <a:latin typeface="Calibri" pitchFamily="34" charset="0"/>
                 <a:ea typeface="Calibri" pitchFamily="34" charset="-122"/>

</xml_diff>

<commit_message>
Usar el logo y colores exactos verificados de Lions Clubs International
Se descargaron los 4 archivos de logo oficiales desde Google Drive
(coincidentes con el kit de marca de Lions Clubs International) y se
extrajeron los colores reales por muestreo de píxeles: azul #00529B y
dorado #FFCF00 (más una variante oscurecida del dorado para texto
legible sobre blanco). Se reemplaza el placeholder decorativo de la
portada por el logo real del Club "Leones en Acción" en el informe y
en la presentación.
Co-Authored-By: Claude Sonnet 5 <noreply@anthropic.com>
Claude-Session: https://claude.ai/code/session_01UWKZXqoHYVxY6r86dsip31
</commit_message>
<xml_diff>
--- a/informes/Presentacion_Modelo_Arriendo_Club_Leones_Z144.pptx
+++ b/informes/Presentacion_Modelo_Arriendo_Club_Leones_Z144.pptx
@@ -1658,7 +1658,7 @@
     <p:bg>
       <p:bgPr>
         <a:solidFill>
-          <a:srgbClr val="001233"/>
+          <a:srgbClr val="002D55"/>
         </a:solidFill>
       </p:bgPr>
     </p:bg>
@@ -1691,7 +1691,7 @@
             <a:avLst/>
           </a:prstGeom>
           <a:solidFill>
-            <a:srgbClr val="0047AB"/>
+            <a:srgbClr val="0066B3"/>
           </a:solidFill>
           <a:ln/>
         </p:spPr>
@@ -1711,190 +1711,41 @@
             <a:avLst/>
           </a:prstGeom>
           <a:solidFill>
-            <a:srgbClr val="00338D"/>
+            <a:srgbClr val="00529B"/>
           </a:solidFill>
           <a:ln/>
         </p:spPr>
       </p:sp>
       <p:sp>
         <p:nvSpPr>
-          <p:cNvPr id="4" name="Text 2"/>
-          <p:cNvSpPr/>
-          <p:nvPr/>
-        </p:nvSpPr>
-        <p:spPr>
-          <a:xfrm>
-            <a:off x="822960" y="1554480"/>
-            <a:ext cx="9144000" cy="365760"/>
-          </a:xfrm>
-          <a:prstGeom prst="rect">
-            <a:avLst/>
-          </a:prstGeom>
-          <a:noFill/>
-          <a:ln/>
-        </p:spPr>
-        <p:txBody>
-          <a:bodyPr wrap="square" rtlCol="0" anchor="ctr"/>
-          <a:lstStyle/>
-          <a:p>
-            <a:pPr indent="0" marL="0">
-              <a:buNone/>
-            </a:pPr>
-            <a:r>
-              <a:rPr lang="en-US" sz="1500" b="1" spc="300" kern="0" dirty="0">
-                <a:solidFill>
-                  <a:srgbClr val="FDB913"/>
-                </a:solidFill>
-                <a:latin typeface="Calibri" pitchFamily="34" charset="0"/>
-                <a:ea typeface="Calibri" pitchFamily="34" charset="-122"/>
-                <a:cs typeface="Calibri" pitchFamily="34" charset="-120"/>
-              </a:rPr>
-              <a:t>CLUB DE LEONES QUINTA NORMAL</a:t>
-            </a:r>
-            <a:endParaRPr lang="en-US" sz="1500" dirty="0"/>
-          </a:p>
-        </p:txBody>
-      </p:sp>
-      <p:sp>
-        <p:nvSpPr>
-          <p:cNvPr id="5" name="Text 3"/>
-          <p:cNvSpPr/>
-          <p:nvPr/>
-        </p:nvSpPr>
-        <p:spPr>
-          <a:xfrm>
-            <a:off x="777240" y="1965960"/>
-            <a:ext cx="10058400" cy="1188720"/>
-          </a:xfrm>
-          <a:prstGeom prst="rect">
-            <a:avLst/>
-          </a:prstGeom>
-          <a:noFill/>
-          <a:ln/>
-        </p:spPr>
-        <p:txBody>
-          <a:bodyPr wrap="square" rtlCol="0" anchor="ctr"/>
-          <a:lstStyle/>
-          <a:p>
-            <a:pPr indent="0" marL="0">
-              <a:buNone/>
-            </a:pPr>
-            <a:r>
-              <a:rPr lang="en-US" sz="5400" b="1" dirty="0">
-                <a:solidFill>
-                  <a:srgbClr val="FFFFFF"/>
-                </a:solidFill>
-                <a:latin typeface="Cambria" pitchFamily="34" charset="0"/>
-                <a:ea typeface="Cambria" pitchFamily="34" charset="-122"/>
-                <a:cs typeface="Cambria" pitchFamily="34" charset="-120"/>
-              </a:rPr>
-              <a:t>Modelo de Arriendo</a:t>
-            </a:r>
-            <a:endParaRPr lang="en-US" sz="5400" dirty="0"/>
-          </a:p>
-        </p:txBody>
-      </p:sp>
-      <p:sp>
-        <p:nvSpPr>
-          <p:cNvPr id="6" name="Text 4"/>
-          <p:cNvSpPr/>
-          <p:nvPr/>
-        </p:nvSpPr>
-        <p:spPr>
-          <a:xfrm>
-            <a:off x="822960" y="3063240"/>
-            <a:ext cx="9601200" cy="548640"/>
-          </a:xfrm>
-          <a:prstGeom prst="rect">
-            <a:avLst/>
-          </a:prstGeom>
-          <a:noFill/>
-          <a:ln/>
-        </p:spPr>
-        <p:txBody>
-          <a:bodyPr wrap="square" rtlCol="0" anchor="ctr"/>
-          <a:lstStyle/>
-          <a:p>
-            <a:pPr indent="0" marL="0">
-              <a:buNone/>
-            </a:pPr>
-            <a:r>
-              <a:rPr lang="en-US" sz="2200" dirty="0">
-                <a:solidFill>
-                  <a:srgbClr val="FFF6DF"/>
-                </a:solidFill>
-                <a:latin typeface="Calibri" pitchFamily="34" charset="0"/>
-                <a:ea typeface="Calibri" pitchFamily="34" charset="-122"/>
-                <a:cs typeface="Calibri" pitchFamily="34" charset="-120"/>
-              </a:rPr>
-              <a:t>Plan piloto de 90 días — Dependencias Z-144</a:t>
-            </a:r>
-            <a:endParaRPr lang="en-US" sz="2200" dirty="0"/>
-          </a:p>
-        </p:txBody>
-      </p:sp>
-      <p:sp>
-        <p:nvSpPr>
-          <p:cNvPr id="7" name="Text 5"/>
-          <p:cNvSpPr/>
-          <p:nvPr/>
-        </p:nvSpPr>
-        <p:spPr>
-          <a:xfrm>
-            <a:off x="822960" y="3566160"/>
-            <a:ext cx="9144000" cy="365760"/>
-          </a:xfrm>
-          <a:prstGeom prst="rect">
-            <a:avLst/>
-          </a:prstGeom>
-          <a:noFill/>
-          <a:ln/>
-        </p:spPr>
-        <p:txBody>
-          <a:bodyPr wrap="square" rtlCol="0" anchor="ctr"/>
-          <a:lstStyle/>
-          <a:p>
-            <a:pPr indent="0" marL="0">
-              <a:buNone/>
-            </a:pPr>
-            <a:r>
-              <a:rPr lang="en-US" sz="1500" i="1" dirty="0">
-                <a:solidFill>
-                  <a:srgbClr val="C9BEDD"/>
-                </a:solidFill>
-                <a:latin typeface="Calibri" pitchFamily="34" charset="0"/>
-                <a:ea typeface="Calibri" pitchFamily="34" charset="-122"/>
-                <a:cs typeface="Calibri" pitchFamily="34" charset="-120"/>
-              </a:rPr>
-              <a:t>Sede "Leones en Acción"</a:t>
-            </a:r>
-            <a:endParaRPr lang="en-US" sz="1500" dirty="0"/>
-          </a:p>
-        </p:txBody>
-      </p:sp>
-      <p:sp>
-        <p:nvSpPr>
-          <p:cNvPr id="8" name="Shape 6"/>
-          <p:cNvSpPr/>
-          <p:nvPr/>
-        </p:nvSpPr>
-        <p:spPr>
-          <a:xfrm>
-            <a:off x="822960" y="4846320"/>
-            <a:ext cx="457200" cy="457200"/>
+          <p:cNvPr id="4" name="Shape 2"/>
+          <p:cNvSpPr/>
+          <p:nvPr/>
+        </p:nvSpPr>
+        <p:spPr>
+          <a:xfrm>
+            <a:off x="9528048" y="365760"/>
+            <a:ext cx="1508760" cy="1508760"/>
           </a:xfrm>
           <a:prstGeom prst="ellipse">
             <a:avLst/>
           </a:prstGeom>
           <a:solidFill>
-            <a:srgbClr val="FDB913"/>
+            <a:srgbClr val="FFFFFF"/>
           </a:solidFill>
           <a:ln/>
+          <a:effectLst>
+            <a:outerShdw sx="100000" sy="100000" kx="0" ky="0" algn="bl" rotWithShape="0" blurRad="127000" dist="38100" dir="5400000">
+              <a:srgbClr val="000000">
+                <a:alpha val="30000"/>
+              </a:srgbClr>
+            </a:outerShdw>
+          </a:effectLst>
         </p:spPr>
       </p:sp>
       <p:pic>
         <p:nvPicPr>
-          <p:cNvPr id="9" name="Image 0" descr="/tmp/claude-0/-home-user-claude/0923df48-5d83-51f5-979f-5e84a3f1a801/scratchpad/ppt/icons/handshake.png">    </p:cNvPr>
+          <p:cNvPr id="5" name="Image 0" descr="/root/.claude/skills/marca-club-leones/assets/logo-leones-en-accion.jpeg">    </p:cNvPr>
           <p:cNvPicPr>
             <a:picLocks noChangeAspect="1"/>
           </p:cNvPicPr>
@@ -1908,6 +1759,206 @@
         </p:blipFill>
         <p:spPr>
           <a:xfrm>
+            <a:off x="9619488" y="457200"/>
+            <a:ext cx="1325880" cy="1313078"/>
+          </a:xfrm>
+          <a:prstGeom prst="rect">
+            <a:avLst/>
+          </a:prstGeom>
+        </p:spPr>
+      </p:pic>
+      <p:sp>
+        <p:nvSpPr>
+          <p:cNvPr id="6" name="Text 3"/>
+          <p:cNvSpPr/>
+          <p:nvPr/>
+        </p:nvSpPr>
+        <p:spPr>
+          <a:xfrm>
+            <a:off x="822960" y="1554480"/>
+            <a:ext cx="9144000" cy="365760"/>
+          </a:xfrm>
+          <a:prstGeom prst="rect">
+            <a:avLst/>
+          </a:prstGeom>
+          <a:noFill/>
+          <a:ln/>
+        </p:spPr>
+        <p:txBody>
+          <a:bodyPr wrap="square" rtlCol="0" anchor="ctr"/>
+          <a:lstStyle/>
+          <a:p>
+            <a:pPr indent="0" marL="0">
+              <a:buNone/>
+            </a:pPr>
+            <a:r>
+              <a:rPr lang="en-US" sz="1500" b="1" spc="300" kern="0" dirty="0">
+                <a:solidFill>
+                  <a:srgbClr val="FFCF00"/>
+                </a:solidFill>
+                <a:latin typeface="Calibri" pitchFamily="34" charset="0"/>
+                <a:ea typeface="Calibri" pitchFamily="34" charset="-122"/>
+                <a:cs typeface="Calibri" pitchFamily="34" charset="-120"/>
+              </a:rPr>
+              <a:t>CLUB DE LEONES QUINTA NORMAL</a:t>
+            </a:r>
+            <a:endParaRPr lang="en-US" sz="1500" dirty="0"/>
+          </a:p>
+        </p:txBody>
+      </p:sp>
+      <p:sp>
+        <p:nvSpPr>
+          <p:cNvPr id="7" name="Text 4"/>
+          <p:cNvSpPr/>
+          <p:nvPr/>
+        </p:nvSpPr>
+        <p:spPr>
+          <a:xfrm>
+            <a:off x="777240" y="1965960"/>
+            <a:ext cx="10058400" cy="1188720"/>
+          </a:xfrm>
+          <a:prstGeom prst="rect">
+            <a:avLst/>
+          </a:prstGeom>
+          <a:noFill/>
+          <a:ln/>
+        </p:spPr>
+        <p:txBody>
+          <a:bodyPr wrap="square" rtlCol="0" anchor="ctr"/>
+          <a:lstStyle/>
+          <a:p>
+            <a:pPr indent="0" marL="0">
+              <a:buNone/>
+            </a:pPr>
+            <a:r>
+              <a:rPr lang="en-US" sz="5400" b="1" dirty="0">
+                <a:solidFill>
+                  <a:srgbClr val="FFFFFF"/>
+                </a:solidFill>
+                <a:latin typeface="Cambria" pitchFamily="34" charset="0"/>
+                <a:ea typeface="Cambria" pitchFamily="34" charset="-122"/>
+                <a:cs typeface="Cambria" pitchFamily="34" charset="-120"/>
+              </a:rPr>
+              <a:t>Modelo de Arriendo</a:t>
+            </a:r>
+            <a:endParaRPr lang="en-US" sz="5400" dirty="0"/>
+          </a:p>
+        </p:txBody>
+      </p:sp>
+      <p:sp>
+        <p:nvSpPr>
+          <p:cNvPr id="8" name="Text 5"/>
+          <p:cNvSpPr/>
+          <p:nvPr/>
+        </p:nvSpPr>
+        <p:spPr>
+          <a:xfrm>
+            <a:off x="822960" y="3063240"/>
+            <a:ext cx="9601200" cy="548640"/>
+          </a:xfrm>
+          <a:prstGeom prst="rect">
+            <a:avLst/>
+          </a:prstGeom>
+          <a:noFill/>
+          <a:ln/>
+        </p:spPr>
+        <p:txBody>
+          <a:bodyPr wrap="square" rtlCol="0" anchor="ctr"/>
+          <a:lstStyle/>
+          <a:p>
+            <a:pPr indent="0" marL="0">
+              <a:buNone/>
+            </a:pPr>
+            <a:r>
+              <a:rPr lang="en-US" sz="2200" dirty="0">
+                <a:solidFill>
+                  <a:srgbClr val="FFF7DD"/>
+                </a:solidFill>
+                <a:latin typeface="Calibri" pitchFamily="34" charset="0"/>
+                <a:ea typeface="Calibri" pitchFamily="34" charset="-122"/>
+                <a:cs typeface="Calibri" pitchFamily="34" charset="-120"/>
+              </a:rPr>
+              <a:t>Plan piloto de 90 días — Dependencias Z-144</a:t>
+            </a:r>
+            <a:endParaRPr lang="en-US" sz="2200" dirty="0"/>
+          </a:p>
+        </p:txBody>
+      </p:sp>
+      <p:sp>
+        <p:nvSpPr>
+          <p:cNvPr id="9" name="Text 6"/>
+          <p:cNvSpPr/>
+          <p:nvPr/>
+        </p:nvSpPr>
+        <p:spPr>
+          <a:xfrm>
+            <a:off x="822960" y="3566160"/>
+            <a:ext cx="9144000" cy="365760"/>
+          </a:xfrm>
+          <a:prstGeom prst="rect">
+            <a:avLst/>
+          </a:prstGeom>
+          <a:noFill/>
+          <a:ln/>
+        </p:spPr>
+        <p:txBody>
+          <a:bodyPr wrap="square" rtlCol="0" anchor="ctr"/>
+          <a:lstStyle/>
+          <a:p>
+            <a:pPr indent="0" marL="0">
+              <a:buNone/>
+            </a:pPr>
+            <a:r>
+              <a:rPr lang="en-US" sz="1500" i="1" dirty="0">
+                <a:solidFill>
+                  <a:srgbClr val="C9BEDD"/>
+                </a:solidFill>
+                <a:latin typeface="Calibri" pitchFamily="34" charset="0"/>
+                <a:ea typeface="Calibri" pitchFamily="34" charset="-122"/>
+                <a:cs typeface="Calibri" pitchFamily="34" charset="-120"/>
+              </a:rPr>
+              <a:t>Sede "Leones en Acción"</a:t>
+            </a:r>
+            <a:endParaRPr lang="en-US" sz="1500" dirty="0"/>
+          </a:p>
+        </p:txBody>
+      </p:sp>
+      <p:sp>
+        <p:nvSpPr>
+          <p:cNvPr id="10" name="Shape 7"/>
+          <p:cNvSpPr/>
+          <p:nvPr/>
+        </p:nvSpPr>
+        <p:spPr>
+          <a:xfrm>
+            <a:off x="822960" y="4846320"/>
+            <a:ext cx="457200" cy="457200"/>
+          </a:xfrm>
+          <a:prstGeom prst="ellipse">
+            <a:avLst/>
+          </a:prstGeom>
+          <a:solidFill>
+            <a:srgbClr val="FFCF00"/>
+          </a:solidFill>
+          <a:ln/>
+        </p:spPr>
+      </p:sp>
+      <p:pic>
+        <p:nvPicPr>
+          <p:cNvPr id="11" name="Image 1" descr="/tmp/claude-0/-home-user-claude/0923df48-5d83-51f5-979f-5e84a3f1a801/scratchpad/ppt/icons/handshake.png">    </p:cNvPr>
+          <p:cNvPicPr>
+            <a:picLocks noChangeAspect="1"/>
+          </p:cNvPicPr>
+          <p:nvPr/>
+        </p:nvPicPr>
+        <p:blipFill>
+          <a:blip r:embed="rId2"/>
+          <a:stretch>
+            <a:fillRect/>
+          </a:stretch>
+        </p:blipFill>
+        <p:spPr>
+          <a:xfrm>
             <a:off x="969264" y="4992624"/>
             <a:ext cx="164592" cy="164592"/>
           </a:xfrm>
@@ -1918,7 +1969,7 @@
       </p:pic>
       <p:sp>
         <p:nvSpPr>
-          <p:cNvPr id="10" name="Text 7"/>
+          <p:cNvPr id="12" name="Text 8"/>
           <p:cNvSpPr/>
           <p:nvPr/>
         </p:nvSpPr>
@@ -1969,7 +2020,7 @@
     <p:bg>
       <p:bgPr>
         <a:solidFill>
-          <a:srgbClr val="001233"/>
+          <a:srgbClr val="002D55"/>
         </a:solidFill>
       </p:bgPr>
     </p:bg>
@@ -2002,7 +2053,7 @@
             <a:avLst/>
           </a:prstGeom>
           <a:solidFill>
-            <a:srgbClr val="0047AB"/>
+            <a:srgbClr val="0066B3"/>
           </a:solidFill>
           <a:ln/>
         </p:spPr>
@@ -2022,7 +2073,7 @@
             <a:avLst/>
           </a:prstGeom>
           <a:solidFill>
-            <a:srgbClr val="FDB913"/>
+            <a:srgbClr val="FFCF00"/>
           </a:solidFill>
           <a:ln/>
         </p:spPr>
@@ -2120,7 +2171,7 @@
             <a:r>
               <a:rPr lang="en-US" sz="1700" dirty="0">
                 <a:solidFill>
-                  <a:srgbClr val="FFF6DF"/>
+                  <a:srgbClr val="FFF7DD"/>
                 </a:solidFill>
                 <a:latin typeface="Calibri" pitchFamily="34" charset="0"/>
                 <a:ea typeface="Calibri" pitchFamily="34" charset="-122"/>
@@ -2147,7 +2198,7 @@
             <a:avLst/>
           </a:prstGeom>
           <a:solidFill>
-            <a:srgbClr val="0047AB"/>
+            <a:srgbClr val="0066B3"/>
           </a:solidFill>
           <a:ln/>
         </p:spPr>
@@ -2230,7 +2281,7 @@
             <a:avLst/>
           </a:prstGeom>
           <a:solidFill>
-            <a:srgbClr val="0047AB"/>
+            <a:srgbClr val="0066B3"/>
           </a:solidFill>
           <a:ln/>
         </p:spPr>
@@ -2313,7 +2364,7 @@
             <a:avLst/>
           </a:prstGeom>
           <a:solidFill>
-            <a:srgbClr val="0047AB"/>
+            <a:srgbClr val="0066B3"/>
           </a:solidFill>
           <a:ln/>
         </p:spPr>
@@ -2396,7 +2447,7 @@
             <a:avLst/>
           </a:prstGeom>
           <a:solidFill>
-            <a:srgbClr val="0047AB"/>
+            <a:srgbClr val="0066B3"/>
           </a:solidFill>
           <a:ln/>
         </p:spPr>
@@ -2562,7 +2613,7 @@
             <a:r>
               <a:rPr lang="en-US" sz="1300" b="1" spc="200" kern="0" dirty="0">
                 <a:solidFill>
-                  <a:srgbClr val="FDB913"/>
+                  <a:srgbClr val="8C7200"/>
                 </a:solidFill>
                 <a:latin typeface="Calibri" pitchFamily="34" charset="0"/>
                 <a:ea typeface="Calibri" pitchFamily="34" charset="-122"/>
@@ -2601,7 +2652,7 @@
             <a:r>
               <a:rPr lang="en-US" sz="3000" b="1" dirty="0">
                 <a:solidFill>
-                  <a:srgbClr val="001233"/>
+                  <a:srgbClr val="002D55"/>
                 </a:solidFill>
                 <a:latin typeface="Cambria" pitchFamily="34" charset="0"/>
                 <a:ea typeface="Cambria" pitchFamily="34" charset="-122"/>
@@ -2685,7 +2736,7 @@
             <a:r>
               <a:rPr lang="en-US" sz="1600" b="1" dirty="0">
                 <a:solidFill>
-                  <a:srgbClr val="001233"/>
+                  <a:srgbClr val="002D55"/>
                 </a:solidFill>
                 <a:latin typeface="Calibri" pitchFamily="34" charset="0"/>
                 <a:ea typeface="Calibri" pitchFamily="34" charset="-122"/>
@@ -2731,7 +2782,7 @@
             </a:avLst>
           </a:prstGeom>
           <a:solidFill>
-            <a:srgbClr val="E9F0FA"/>
+            <a:srgbClr val="E8F0F8"/>
           </a:solidFill>
           <a:ln/>
           <a:effectLst>
@@ -2758,7 +2809,7 @@
             <a:avLst/>
           </a:prstGeom>
           <a:solidFill>
-            <a:srgbClr val="00338D"/>
+            <a:srgbClr val="00529B"/>
           </a:solidFill>
           <a:ln/>
         </p:spPr>
@@ -2814,7 +2865,7 @@
             <a:r>
               <a:rPr lang="en-US" sz="1600" b="1" dirty="0">
                 <a:solidFill>
-                  <a:srgbClr val="001233"/>
+                  <a:srgbClr val="002D55"/>
                 </a:solidFill>
                 <a:latin typeface="Calibri" pitchFamily="34" charset="0"/>
                 <a:ea typeface="Calibri" pitchFamily="34" charset="-122"/>
@@ -2853,7 +2904,7 @@
             <a:r>
               <a:rPr lang="en-US" sz="4000" b="1" dirty="0">
                 <a:solidFill>
-                  <a:srgbClr val="001233"/>
+                  <a:srgbClr val="002D55"/>
                 </a:solidFill>
                 <a:latin typeface="Cambria" pitchFamily="34" charset="0"/>
                 <a:ea typeface="Cambria" pitchFamily="34" charset="-122"/>
@@ -3080,7 +3131,7 @@
             <a:r>
               <a:rPr lang="en-US" sz="1300" b="1" spc="200" kern="0" dirty="0">
                 <a:solidFill>
-                  <a:srgbClr val="FDB913"/>
+                  <a:srgbClr val="8C7200"/>
                 </a:solidFill>
                 <a:latin typeface="Calibri" pitchFamily="34" charset="0"/>
                 <a:ea typeface="Calibri" pitchFamily="34" charset="-122"/>
@@ -3119,7 +3170,7 @@
             <a:r>
               <a:rPr lang="en-US" sz="3000" b="1" dirty="0">
                 <a:solidFill>
-                  <a:srgbClr val="001233"/>
+                  <a:srgbClr val="002D55"/>
                 </a:solidFill>
                 <a:latin typeface="Cambria" pitchFamily="34" charset="0"/>
                 <a:ea typeface="Cambria" pitchFamily="34" charset="-122"/>
@@ -3148,7 +3199,7 @@
             </a:avLst>
           </a:prstGeom>
           <a:solidFill>
-            <a:srgbClr val="00338D"/>
+            <a:srgbClr val="00529B"/>
           </a:solidFill>
           <a:ln/>
         </p:spPr>
@@ -3168,7 +3219,7 @@
             <a:avLst/>
           </a:prstGeom>
           <a:solidFill>
-            <a:srgbClr val="FDB913"/>
+            <a:srgbClr val="FFCF00"/>
           </a:solidFill>
           <a:ln/>
         </p:spPr>
@@ -3256,7 +3307,7 @@
             </a:avLst>
           </a:prstGeom>
           <a:solidFill>
-            <a:srgbClr val="E9F0FA"/>
+            <a:srgbClr val="E8F0F8"/>
           </a:solidFill>
           <a:ln/>
         </p:spPr>
@@ -3288,7 +3339,7 @@
             <a:r>
               <a:rPr lang="en-US" sz="3200" b="1" dirty="0">
                 <a:solidFill>
-                  <a:srgbClr val="001233"/>
+                  <a:srgbClr val="002D55"/>
                 </a:solidFill>
                 <a:latin typeface="Cambria" pitchFamily="34" charset="0"/>
                 <a:ea typeface="Cambria" pitchFamily="34" charset="-122"/>
@@ -3356,7 +3407,7 @@
             </a:avLst>
           </a:prstGeom>
           <a:solidFill>
-            <a:srgbClr val="E9F0FA"/>
+            <a:srgbClr val="E8F0F8"/>
           </a:solidFill>
           <a:ln/>
         </p:spPr>
@@ -3388,7 +3439,7 @@
             <a:r>
               <a:rPr lang="en-US" sz="3200" b="1" dirty="0">
                 <a:solidFill>
-                  <a:srgbClr val="001233"/>
+                  <a:srgbClr val="002D55"/>
                 </a:solidFill>
                 <a:latin typeface="Cambria" pitchFamily="34" charset="0"/>
                 <a:ea typeface="Cambria" pitchFamily="34" charset="-122"/>
@@ -3456,7 +3507,7 @@
             </a:avLst>
           </a:prstGeom>
           <a:solidFill>
-            <a:srgbClr val="E9F0FA"/>
+            <a:srgbClr val="E8F0F8"/>
           </a:solidFill>
           <a:ln/>
         </p:spPr>
@@ -3488,7 +3539,7 @@
             <a:r>
               <a:rPr lang="en-US" sz="3200" b="1" dirty="0">
                 <a:solidFill>
-                  <a:srgbClr val="001233"/>
+                  <a:srgbClr val="002D55"/>
                 </a:solidFill>
                 <a:latin typeface="Cambria" pitchFamily="34" charset="0"/>
                 <a:ea typeface="Cambria" pitchFamily="34" charset="-122"/>
@@ -3556,7 +3607,7 @@
             </a:avLst>
           </a:prstGeom>
           <a:solidFill>
-            <a:srgbClr val="E9F0FA"/>
+            <a:srgbClr val="E8F0F8"/>
           </a:solidFill>
           <a:ln/>
         </p:spPr>
@@ -3588,7 +3639,7 @@
             <a:r>
               <a:rPr lang="en-US" sz="3200" b="1" dirty="0">
                 <a:solidFill>
-                  <a:srgbClr val="001233"/>
+                  <a:srgbClr val="002D55"/>
                 </a:solidFill>
                 <a:latin typeface="Cambria" pitchFamily="34" charset="0"/>
                 <a:ea typeface="Cambria" pitchFamily="34" charset="-122"/>
@@ -3776,7 +3827,7 @@
             <a:r>
               <a:rPr lang="en-US" sz="1300" b="1" spc="200" kern="0" dirty="0">
                 <a:solidFill>
-                  <a:srgbClr val="FDB913"/>
+                  <a:srgbClr val="8C7200"/>
                 </a:solidFill>
                 <a:latin typeface="Calibri" pitchFamily="34" charset="0"/>
                 <a:ea typeface="Calibri" pitchFamily="34" charset="-122"/>
@@ -3815,7 +3866,7 @@
             <a:r>
               <a:rPr lang="en-US" sz="3000" b="1" dirty="0">
                 <a:solidFill>
-                  <a:srgbClr val="001233"/>
+                  <a:srgbClr val="002D55"/>
                 </a:solidFill>
                 <a:latin typeface="Cambria" pitchFamily="34" charset="0"/>
                 <a:ea typeface="Cambria" pitchFamily="34" charset="-122"/>
@@ -3842,7 +3893,7 @@
             <a:avLst/>
           </a:prstGeom>
           <a:solidFill>
-            <a:srgbClr val="00338D"/>
+            <a:srgbClr val="00529B"/>
           </a:solidFill>
           <a:ln/>
         </p:spPr>
@@ -3928,7 +3979,7 @@
             <a:avLst/>
           </a:prstGeom>
           <a:solidFill>
-            <a:srgbClr val="00338D"/>
+            <a:srgbClr val="00529B"/>
           </a:solidFill>
           <a:ln/>
         </p:spPr>
@@ -4014,7 +4065,7 @@
             <a:avLst/>
           </a:prstGeom>
           <a:solidFill>
-            <a:srgbClr val="00338D"/>
+            <a:srgbClr val="00529B"/>
           </a:solidFill>
           <a:ln/>
         </p:spPr>
@@ -4100,7 +4151,7 @@
             <a:avLst/>
           </a:prstGeom>
           <a:solidFill>
-            <a:srgbClr val="00338D"/>
+            <a:srgbClr val="00529B"/>
           </a:solidFill>
           <a:ln/>
         </p:spPr>
@@ -4186,7 +4237,7 @@
             <a:avLst/>
           </a:prstGeom>
           <a:solidFill>
-            <a:srgbClr val="00338D"/>
+            <a:srgbClr val="00529B"/>
           </a:solidFill>
           <a:ln/>
         </p:spPr>
@@ -4394,7 +4445,7 @@
             <a:r>
               <a:rPr lang="en-US" sz="1300" b="1" spc="200" kern="0" dirty="0">
                 <a:solidFill>
-                  <a:srgbClr val="FDB913"/>
+                  <a:srgbClr val="8C7200"/>
                 </a:solidFill>
                 <a:latin typeface="Calibri" pitchFamily="34" charset="0"/>
                 <a:ea typeface="Calibri" pitchFamily="34" charset="-122"/>
@@ -4433,7 +4484,7 @@
             <a:r>
               <a:rPr lang="en-US" sz="3000" b="1" dirty="0">
                 <a:solidFill>
-                  <a:srgbClr val="001233"/>
+                  <a:srgbClr val="002D55"/>
                 </a:solidFill>
                 <a:latin typeface="Cambria" pitchFamily="34" charset="0"/>
                 <a:ea typeface="Cambria" pitchFamily="34" charset="-122"/>
@@ -4501,7 +4552,7 @@
             </a:avLst>
           </a:prstGeom>
           <a:solidFill>
-            <a:srgbClr val="E9F0FA"/>
+            <a:srgbClr val="E8F0F8"/>
           </a:solidFill>
           <a:ln/>
         </p:spPr>
@@ -4533,7 +4584,7 @@
             <a:r>
               <a:rPr lang="en-US" sz="1700" b="1" dirty="0">
                 <a:solidFill>
-                  <a:srgbClr val="001233"/>
+                  <a:srgbClr val="002D55"/>
                 </a:solidFill>
                 <a:latin typeface="Calibri" pitchFamily="34" charset="0"/>
                 <a:ea typeface="Calibri" pitchFamily="34" charset="-122"/>
@@ -4680,7 +4731,7 @@
             </a:avLst>
           </a:prstGeom>
           <a:solidFill>
-            <a:srgbClr val="FFF6DF"/>
+            <a:srgbClr val="FFF7DD"/>
           </a:solidFill>
           <a:ln/>
         </p:spPr>
@@ -4712,7 +4763,7 @@
             <a:r>
               <a:rPr lang="en-US" sz="1700" b="1" dirty="0">
                 <a:solidFill>
-                  <a:srgbClr val="001233"/>
+                  <a:srgbClr val="002D55"/>
                 </a:solidFill>
                 <a:latin typeface="Calibri" pitchFamily="34" charset="0"/>
                 <a:ea typeface="Calibri" pitchFamily="34" charset="-122"/>
@@ -4979,7 +5030,7 @@
             <a:r>
               <a:rPr lang="en-US" sz="1300" b="1" spc="200" kern="0" dirty="0">
                 <a:solidFill>
-                  <a:srgbClr val="FDB913"/>
+                  <a:srgbClr val="8C7200"/>
                 </a:solidFill>
                 <a:latin typeface="Calibri" pitchFamily="34" charset="0"/>
                 <a:ea typeface="Calibri" pitchFamily="34" charset="-122"/>
@@ -5018,7 +5069,7 @@
             <a:r>
               <a:rPr lang="en-US" sz="3000" b="1" dirty="0">
                 <a:solidFill>
-                  <a:srgbClr val="001233"/>
+                  <a:srgbClr val="002D55"/>
                 </a:solidFill>
                 <a:latin typeface="Cambria" pitchFamily="34" charset="0"/>
                 <a:ea typeface="Cambria" pitchFamily="34" charset="-122"/>
@@ -5124,7 +5175,7 @@
                       <a:tailEnd type="none" w="med" len="med"/>
                     </a:lnB>
                     <a:solidFill>
-                      <a:srgbClr val="00338D"/>
+                      <a:srgbClr val="00529B"/>
                     </a:solidFill>
                   </a:tcPr>
                 </a:tc>
@@ -5192,7 +5243,7 @@
                       <a:tailEnd type="none" w="med" len="med"/>
                     </a:lnB>
                     <a:solidFill>
-                      <a:srgbClr val="00338D"/>
+                      <a:srgbClr val="00529B"/>
                     </a:solidFill>
                   </a:tcPr>
                 </a:tc>
@@ -5260,7 +5311,7 @@
                       <a:tailEnd type="none" w="med" len="med"/>
                     </a:lnB>
                     <a:solidFill>
-                      <a:srgbClr val="00338D"/>
+                      <a:srgbClr val="00529B"/>
                     </a:solidFill>
                   </a:tcPr>
                 </a:tc>
@@ -5328,7 +5379,7 @@
                       <a:tailEnd type="none" w="med" len="med"/>
                     </a:lnB>
                     <a:solidFill>
-                      <a:srgbClr val="00338D"/>
+                      <a:srgbClr val="00529B"/>
                     </a:solidFill>
                   </a:tcPr>
                 </a:tc>
@@ -5396,7 +5447,7 @@
                       <a:tailEnd type="none" w="med" len="med"/>
                     </a:lnB>
                     <a:solidFill>
-                      <a:srgbClr val="00338D"/>
+                      <a:srgbClr val="00529B"/>
                     </a:solidFill>
                   </a:tcPr>
                 </a:tc>
@@ -5466,7 +5517,7 @@
                       <a:tailEnd type="none" w="med" len="med"/>
                     </a:lnB>
                     <a:solidFill>
-                      <a:srgbClr val="E9F0FA"/>
+                      <a:srgbClr val="E8F0F8"/>
                     </a:solidFill>
                   </a:tcPr>
                 </a:tc>
@@ -5534,7 +5585,7 @@
                       <a:tailEnd type="none" w="med" len="med"/>
                     </a:lnB>
                     <a:solidFill>
-                      <a:srgbClr val="E9F0FA"/>
+                      <a:srgbClr val="E8F0F8"/>
                     </a:solidFill>
                   </a:tcPr>
                 </a:tc>
@@ -5602,7 +5653,7 @@
                       <a:tailEnd type="none" w="med" len="med"/>
                     </a:lnB>
                     <a:solidFill>
-                      <a:srgbClr val="E9F0FA"/>
+                      <a:srgbClr val="E8F0F8"/>
                     </a:solidFill>
                   </a:tcPr>
                 </a:tc>
@@ -5670,7 +5721,7 @@
                       <a:tailEnd type="none" w="med" len="med"/>
                     </a:lnB>
                     <a:solidFill>
-                      <a:srgbClr val="E9F0FA"/>
+                      <a:srgbClr val="E8F0F8"/>
                     </a:solidFill>
                   </a:tcPr>
                 </a:tc>
@@ -5738,7 +5789,7 @@
                       <a:tailEnd type="none" w="med" len="med"/>
                     </a:lnB>
                     <a:solidFill>
-                      <a:srgbClr val="E9F0FA"/>
+                      <a:srgbClr val="E8F0F8"/>
                     </a:solidFill>
                   </a:tcPr>
                 </a:tc>
@@ -6150,7 +6201,7 @@
                       <a:tailEnd type="none" w="med" len="med"/>
                     </a:lnB>
                     <a:solidFill>
-                      <a:srgbClr val="E9F0FA"/>
+                      <a:srgbClr val="E8F0F8"/>
                     </a:solidFill>
                   </a:tcPr>
                 </a:tc>
@@ -6218,7 +6269,7 @@
                       <a:tailEnd type="none" w="med" len="med"/>
                     </a:lnB>
                     <a:solidFill>
-                      <a:srgbClr val="E9F0FA"/>
+                      <a:srgbClr val="E8F0F8"/>
                     </a:solidFill>
                   </a:tcPr>
                 </a:tc>
@@ -6286,7 +6337,7 @@
                       <a:tailEnd type="none" w="med" len="med"/>
                     </a:lnB>
                     <a:solidFill>
-                      <a:srgbClr val="E9F0FA"/>
+                      <a:srgbClr val="E8F0F8"/>
                     </a:solidFill>
                   </a:tcPr>
                 </a:tc>
@@ -6354,7 +6405,7 @@
                       <a:tailEnd type="none" w="med" len="med"/>
                     </a:lnB>
                     <a:solidFill>
-                      <a:srgbClr val="E9F0FA"/>
+                      <a:srgbClr val="E8F0F8"/>
                     </a:solidFill>
                   </a:tcPr>
                 </a:tc>
@@ -6422,7 +6473,7 @@
                       <a:tailEnd type="none" w="med" len="med"/>
                     </a:lnB>
                     <a:solidFill>
-                      <a:srgbClr val="E9F0FA"/>
+                      <a:srgbClr val="E8F0F8"/>
                     </a:solidFill>
                   </a:tcPr>
                 </a:tc>
@@ -6448,7 +6499,7 @@
             </a:avLst>
           </a:prstGeom>
           <a:solidFill>
-            <a:srgbClr val="FFF6DF"/>
+            <a:srgbClr val="FFF7DD"/>
           </a:solidFill>
           <a:ln/>
         </p:spPr>
@@ -6483,7 +6534,7 @@
             <a:r>
               <a:rPr lang="en-US" sz="1400" b="1" dirty="0">
                 <a:solidFill>
-                  <a:srgbClr val="001233"/>
+                  <a:srgbClr val="002D55"/>
                 </a:solidFill>
                 <a:latin typeface="Calibri" pitchFamily="34" charset="0"/>
                 <a:ea typeface="Calibri" pitchFamily="34" charset="-122"/>
@@ -6688,7 +6739,7 @@
             <a:r>
               <a:rPr lang="en-US" sz="1300" b="1" spc="200" kern="0" dirty="0">
                 <a:solidFill>
-                  <a:srgbClr val="FDB913"/>
+                  <a:srgbClr val="8C7200"/>
                 </a:solidFill>
                 <a:latin typeface="Calibri" pitchFamily="34" charset="0"/>
                 <a:ea typeface="Calibri" pitchFamily="34" charset="-122"/>
@@ -6727,7 +6778,7 @@
             <a:r>
               <a:rPr lang="en-US" sz="3000" b="1" dirty="0">
                 <a:solidFill>
-                  <a:srgbClr val="001233"/>
+                  <a:srgbClr val="002D55"/>
                 </a:solidFill>
                 <a:latin typeface="Cambria" pitchFamily="34" charset="0"/>
                 <a:ea typeface="Cambria" pitchFamily="34" charset="-122"/>
@@ -6756,7 +6807,7 @@
             </a:avLst>
           </a:prstGeom>
           <a:solidFill>
-            <a:srgbClr val="E9F0FA"/>
+            <a:srgbClr val="E8F0F8"/>
           </a:solidFill>
           <a:ln/>
         </p:spPr>
@@ -6776,7 +6827,7 @@
             <a:avLst/>
           </a:prstGeom>
           <a:solidFill>
-            <a:srgbClr val="00338D"/>
+            <a:srgbClr val="00529B"/>
           </a:solidFill>
           <a:ln/>
         </p:spPr>
@@ -6832,7 +6883,7 @@
             <a:r>
               <a:rPr lang="en-US" sz="1700" b="1" dirty="0">
                 <a:solidFill>
-                  <a:srgbClr val="001233"/>
+                  <a:srgbClr val="002D55"/>
                 </a:solidFill>
                 <a:latin typeface="Calibri" pitchFamily="34" charset="0"/>
                 <a:ea typeface="Calibri" pitchFamily="34" charset="-122"/>
@@ -6943,7 +6994,7 @@
             </a:avLst>
           </a:prstGeom>
           <a:solidFill>
-            <a:srgbClr val="E9F0FA"/>
+            <a:srgbClr val="E8F0F8"/>
           </a:solidFill>
           <a:ln/>
         </p:spPr>
@@ -6963,7 +7014,7 @@
             <a:avLst/>
           </a:prstGeom>
           <a:solidFill>
-            <a:srgbClr val="00338D"/>
+            <a:srgbClr val="00529B"/>
           </a:solidFill>
           <a:ln/>
         </p:spPr>
@@ -7019,7 +7070,7 @@
             <a:r>
               <a:rPr lang="en-US" sz="1700" b="1" dirty="0">
                 <a:solidFill>
-                  <a:srgbClr val="001233"/>
+                  <a:srgbClr val="002D55"/>
                 </a:solidFill>
                 <a:latin typeface="Calibri" pitchFamily="34" charset="0"/>
                 <a:ea typeface="Calibri" pitchFamily="34" charset="-122"/>
@@ -7130,7 +7181,7 @@
             </a:avLst>
           </a:prstGeom>
           <a:solidFill>
-            <a:srgbClr val="E9F0FA"/>
+            <a:srgbClr val="E8F0F8"/>
           </a:solidFill>
           <a:ln/>
         </p:spPr>
@@ -7150,7 +7201,7 @@
             <a:avLst/>
           </a:prstGeom>
           <a:solidFill>
-            <a:srgbClr val="00338D"/>
+            <a:srgbClr val="00529B"/>
           </a:solidFill>
           <a:ln/>
         </p:spPr>
@@ -7206,7 +7257,7 @@
             <a:r>
               <a:rPr lang="en-US" sz="1700" b="1" dirty="0">
                 <a:solidFill>
-                  <a:srgbClr val="001233"/>
+                  <a:srgbClr val="002D55"/>
                 </a:solidFill>
                 <a:latin typeface="Calibri" pitchFamily="34" charset="0"/>
                 <a:ea typeface="Calibri" pitchFamily="34" charset="-122"/>
@@ -7437,7 +7488,7 @@
             <a:r>
               <a:rPr lang="en-US" sz="1300" b="1" spc="200" kern="0" dirty="0">
                 <a:solidFill>
-                  <a:srgbClr val="FDB913"/>
+                  <a:srgbClr val="8C7200"/>
                 </a:solidFill>
                 <a:latin typeface="Calibri" pitchFamily="34" charset="0"/>
                 <a:ea typeface="Calibri" pitchFamily="34" charset="-122"/>
@@ -7476,7 +7527,7 @@
             <a:r>
               <a:rPr lang="en-US" sz="3000" b="1" dirty="0">
                 <a:solidFill>
-                  <a:srgbClr val="001233"/>
+                  <a:srgbClr val="002D55"/>
                 </a:solidFill>
                 <a:latin typeface="Cambria" pitchFamily="34" charset="0"/>
                 <a:ea typeface="Cambria" pitchFamily="34" charset="-122"/>
@@ -7618,7 +7669,7 @@
                       <a:tailEnd type="none" w="med" len="med"/>
                     </a:lnB>
                     <a:solidFill>
-                      <a:srgbClr val="00338D"/>
+                      <a:srgbClr val="00529B"/>
                     </a:solidFill>
                   </a:tcPr>
                 </a:tc>
@@ -7686,7 +7737,7 @@
                       <a:tailEnd type="none" w="med" len="med"/>
                     </a:lnB>
                     <a:solidFill>
-                      <a:srgbClr val="00338D"/>
+                      <a:srgbClr val="00529B"/>
                     </a:solidFill>
                   </a:tcPr>
                 </a:tc>
@@ -7756,7 +7807,7 @@
                       <a:tailEnd type="none" w="med" len="med"/>
                     </a:lnB>
                     <a:solidFill>
-                      <a:srgbClr val="E9F0FA"/>
+                      <a:srgbClr val="E8F0F8"/>
                     </a:solidFill>
                   </a:tcPr>
                 </a:tc>
@@ -7824,7 +7875,7 @@
                       <a:tailEnd type="none" w="med" len="med"/>
                     </a:lnB>
                     <a:solidFill>
-                      <a:srgbClr val="E9F0FA"/>
+                      <a:srgbClr val="E8F0F8"/>
                     </a:solidFill>
                   </a:tcPr>
                 </a:tc>
@@ -8032,7 +8083,7 @@
                       <a:tailEnd type="none" w="med" len="med"/>
                     </a:lnB>
                     <a:solidFill>
-                      <a:srgbClr val="E9F0FA"/>
+                      <a:srgbClr val="E8F0F8"/>
                     </a:solidFill>
                   </a:tcPr>
                 </a:tc>
@@ -8100,7 +8151,7 @@
                       <a:tailEnd type="none" w="med" len="med"/>
                     </a:lnB>
                     <a:solidFill>
-                      <a:srgbClr val="E9F0FA"/>
+                      <a:srgbClr val="E8F0F8"/>
                     </a:solidFill>
                   </a:tcPr>
                 </a:tc>
@@ -8308,7 +8359,7 @@
                       <a:tailEnd type="none" w="med" len="med"/>
                     </a:lnB>
                     <a:solidFill>
-                      <a:srgbClr val="E9F0FA"/>
+                      <a:srgbClr val="E8F0F8"/>
                     </a:solidFill>
                   </a:tcPr>
                 </a:tc>
@@ -8376,7 +8427,7 @@
                       <a:tailEnd type="none" w="med" len="med"/>
                     </a:lnB>
                     <a:solidFill>
-                      <a:srgbClr val="E9F0FA"/>
+                      <a:srgbClr val="E8F0F8"/>
                     </a:solidFill>
                   </a:tcPr>
                 </a:tc>
@@ -8660,7 +8711,7 @@
             <a:r>
               <a:rPr lang="en-US" sz="1300" b="1" spc="200" kern="0" dirty="0">
                 <a:solidFill>
-                  <a:srgbClr val="FDB913"/>
+                  <a:srgbClr val="8C7200"/>
                 </a:solidFill>
                 <a:latin typeface="Calibri" pitchFamily="34" charset="0"/>
                 <a:ea typeface="Calibri" pitchFamily="34" charset="-122"/>
@@ -8699,7 +8750,7 @@
             <a:r>
               <a:rPr lang="en-US" sz="3000" b="1" dirty="0">
                 <a:solidFill>
-                  <a:srgbClr val="001233"/>
+                  <a:srgbClr val="002D55"/>
                 </a:solidFill>
                 <a:latin typeface="Cambria" pitchFamily="34" charset="0"/>
                 <a:ea typeface="Cambria" pitchFamily="34" charset="-122"/>
@@ -8728,7 +8779,7 @@
           <a:noFill/>
           <a:ln w="31750">
             <a:solidFill>
-              <a:srgbClr val="FDB913"/>
+              <a:srgbClr val="FFCF00"/>
             </a:solidFill>
             <a:prstDash val="dash"/>
           </a:ln>
@@ -8749,7 +8800,7 @@
             <a:avLst/>
           </a:prstGeom>
           <a:solidFill>
-            <a:srgbClr val="00338D"/>
+            <a:srgbClr val="00529B"/>
           </a:solidFill>
           <a:ln w="25400">
             <a:solidFill>
@@ -8815,7 +8866,7 @@
             </a:avLst>
           </a:prstGeom>
           <a:solidFill>
-            <a:srgbClr val="E9F0FA"/>
+            <a:srgbClr val="E8F0F8"/>
           </a:solidFill>
           <a:ln/>
         </p:spPr>
@@ -8847,7 +8898,7 @@
             <a:r>
               <a:rPr lang="en-US" sz="1200" b="1" dirty="0">
                 <a:solidFill>
-                  <a:srgbClr val="B8860B"/>
+                  <a:srgbClr val="8C7200"/>
                 </a:solidFill>
                 <a:latin typeface="Calibri" pitchFamily="34" charset="0"/>
                 <a:ea typeface="Calibri" pitchFamily="34" charset="-122"/>
@@ -8886,7 +8937,7 @@
             <a:r>
               <a:rPr lang="en-US" sz="1600" b="1" dirty="0">
                 <a:solidFill>
-                  <a:srgbClr val="001233"/>
+                  <a:srgbClr val="002D55"/>
                 </a:solidFill>
                 <a:latin typeface="Calibri" pitchFamily="34" charset="0"/>
                 <a:ea typeface="Calibri" pitchFamily="34" charset="-122"/>
@@ -8952,7 +9003,7 @@
             <a:avLst/>
           </a:prstGeom>
           <a:solidFill>
-            <a:srgbClr val="00338D"/>
+            <a:srgbClr val="00529B"/>
           </a:solidFill>
           <a:ln w="25400">
             <a:solidFill>
@@ -9018,7 +9069,7 @@
             </a:avLst>
           </a:prstGeom>
           <a:solidFill>
-            <a:srgbClr val="E9F0FA"/>
+            <a:srgbClr val="E8F0F8"/>
           </a:solidFill>
           <a:ln/>
         </p:spPr>
@@ -9050,7 +9101,7 @@
             <a:r>
               <a:rPr lang="en-US" sz="1200" b="1" dirty="0">
                 <a:solidFill>
-                  <a:srgbClr val="B8860B"/>
+                  <a:srgbClr val="8C7200"/>
                 </a:solidFill>
                 <a:latin typeface="Calibri" pitchFamily="34" charset="0"/>
                 <a:ea typeface="Calibri" pitchFamily="34" charset="-122"/>
@@ -9089,7 +9140,7 @@
             <a:r>
               <a:rPr lang="en-US" sz="1600" b="1" dirty="0">
                 <a:solidFill>
-                  <a:srgbClr val="001233"/>
+                  <a:srgbClr val="002D55"/>
                 </a:solidFill>
                 <a:latin typeface="Calibri" pitchFamily="34" charset="0"/>
                 <a:ea typeface="Calibri" pitchFamily="34" charset="-122"/>
@@ -9155,7 +9206,7 @@
             <a:avLst/>
           </a:prstGeom>
           <a:solidFill>
-            <a:srgbClr val="00338D"/>
+            <a:srgbClr val="00529B"/>
           </a:solidFill>
           <a:ln w="25400">
             <a:solidFill>
@@ -9221,7 +9272,7 @@
             </a:avLst>
           </a:prstGeom>
           <a:solidFill>
-            <a:srgbClr val="E9F0FA"/>
+            <a:srgbClr val="E8F0F8"/>
           </a:solidFill>
           <a:ln/>
         </p:spPr>
@@ -9253,7 +9304,7 @@
             <a:r>
               <a:rPr lang="en-US" sz="1200" b="1" dirty="0">
                 <a:solidFill>
-                  <a:srgbClr val="B8860B"/>
+                  <a:srgbClr val="8C7200"/>
                 </a:solidFill>
                 <a:latin typeface="Calibri" pitchFamily="34" charset="0"/>
                 <a:ea typeface="Calibri" pitchFamily="34" charset="-122"/>
@@ -9292,7 +9343,7 @@
             <a:r>
               <a:rPr lang="en-US" sz="1600" b="1" dirty="0">
                 <a:solidFill>
-                  <a:srgbClr val="001233"/>
+                  <a:srgbClr val="002D55"/>
                 </a:solidFill>
                 <a:latin typeface="Calibri" pitchFamily="34" charset="0"/>
                 <a:ea typeface="Calibri" pitchFamily="34" charset="-122"/>
@@ -9358,7 +9409,7 @@
             <a:avLst/>
           </a:prstGeom>
           <a:solidFill>
-            <a:srgbClr val="00338D"/>
+            <a:srgbClr val="00529B"/>
           </a:solidFill>
           <a:ln w="25400">
             <a:solidFill>
@@ -9424,7 +9475,7 @@
             </a:avLst>
           </a:prstGeom>
           <a:solidFill>
-            <a:srgbClr val="E9F0FA"/>
+            <a:srgbClr val="E8F0F8"/>
           </a:solidFill>
           <a:ln/>
         </p:spPr>
@@ -9456,7 +9507,7 @@
             <a:r>
               <a:rPr lang="en-US" sz="1200" b="1" dirty="0">
                 <a:solidFill>
-                  <a:srgbClr val="B8860B"/>
+                  <a:srgbClr val="8C7200"/>
                 </a:solidFill>
                 <a:latin typeface="Calibri" pitchFamily="34" charset="0"/>
                 <a:ea typeface="Calibri" pitchFamily="34" charset="-122"/>
@@ -9495,7 +9546,7 @@
             <a:r>
               <a:rPr lang="en-US" sz="1600" b="1" dirty="0">
                 <a:solidFill>
-                  <a:srgbClr val="001233"/>
+                  <a:srgbClr val="002D55"/>
                 </a:solidFill>
                 <a:latin typeface="Calibri" pitchFamily="34" charset="0"/>
                 <a:ea typeface="Calibri" pitchFamily="34" charset="-122"/>
@@ -9573,7 +9624,7 @@
             <a:r>
               <a:rPr lang="en-US" sz="1600" b="1" dirty="0">
                 <a:solidFill>
-                  <a:srgbClr val="001233"/>
+                  <a:srgbClr val="002D55"/>
                 </a:solidFill>
                 <a:latin typeface="Calibri" pitchFamily="34" charset="0"/>
                 <a:ea typeface="Calibri" pitchFamily="34" charset="-122"/>
@@ -9600,7 +9651,7 @@
             <a:avLst/>
           </a:prstGeom>
           <a:solidFill>
-            <a:srgbClr val="00338D"/>
+            <a:srgbClr val="00529B"/>
           </a:solidFill>
           <a:ln/>
         </p:spPr>
@@ -9656,7 +9707,7 @@
             <a:r>
               <a:rPr lang="en-US" sz="1300" b="1" dirty="0">
                 <a:solidFill>
-                  <a:srgbClr val="001233"/>
+                  <a:srgbClr val="002D55"/>
                 </a:solidFill>
                 <a:latin typeface="Calibri" pitchFamily="34" charset="0"/>
                 <a:ea typeface="Calibri" pitchFamily="34" charset="-122"/>
@@ -9722,7 +9773,7 @@
             <a:avLst/>
           </a:prstGeom>
           <a:solidFill>
-            <a:srgbClr val="00338D"/>
+            <a:srgbClr val="00529B"/>
           </a:solidFill>
           <a:ln/>
         </p:spPr>
@@ -9778,7 +9829,7 @@
             <a:r>
               <a:rPr lang="en-US" sz="1300" b="1" dirty="0">
                 <a:solidFill>
-                  <a:srgbClr val="001233"/>
+                  <a:srgbClr val="002D55"/>
                 </a:solidFill>
                 <a:latin typeface="Calibri" pitchFamily="34" charset="0"/>
                 <a:ea typeface="Calibri" pitchFamily="34" charset="-122"/>
@@ -9844,7 +9895,7 @@
             <a:avLst/>
           </a:prstGeom>
           <a:solidFill>
-            <a:srgbClr val="00338D"/>
+            <a:srgbClr val="00529B"/>
           </a:solidFill>
           <a:ln/>
         </p:spPr>
@@ -9900,7 +9951,7 @@
             <a:r>
               <a:rPr lang="en-US" sz="1300" b="1" dirty="0">
                 <a:solidFill>
-                  <a:srgbClr val="001233"/>
+                  <a:srgbClr val="002D55"/>
                 </a:solidFill>
                 <a:latin typeface="Calibri" pitchFamily="34" charset="0"/>
                 <a:ea typeface="Calibri" pitchFamily="34" charset="-122"/>
@@ -9966,7 +10017,7 @@
             <a:avLst/>
           </a:prstGeom>
           <a:solidFill>
-            <a:srgbClr val="00338D"/>
+            <a:srgbClr val="00529B"/>
           </a:solidFill>
           <a:ln/>
         </p:spPr>
@@ -10022,7 +10073,7 @@
             <a:r>
               <a:rPr lang="en-US" sz="1300" b="1" dirty="0">
                 <a:solidFill>
-                  <a:srgbClr val="001233"/>
+                  <a:srgbClr val="002D55"/>
                 </a:solidFill>
                 <a:latin typeface="Calibri" pitchFamily="34" charset="0"/>
                 <a:ea typeface="Calibri" pitchFamily="34" charset="-122"/>

</xml_diff>